<commit_message>
Pitch: footer gives HubAI's own start (first commit Sat 10:37)
Co-Authored-By: Claude Opus 5.5 <noreply@anthropic.com>
</commit_message>
<xml_diff>
--- a/planning/hubai-pitch.pptx
+++ b/planning/hubai-pitch.pptx
@@ -110,22 +110,22 @@
   <p:extLst>
     <p:ext uri="{521415D9-36F7-43E2-AB2F-B90AF26B5E84}">
       <p14:sectionLst xmlns:p14="http://schemas.microsoft.com/office/powerpoint/2010/main">
-        <p14:section name="Problem" id="{e905f2a3-dd8a-26ab-32e6-dcf91ea0a6ca}">
+        <p14:section name="Problem" id="{1d8a2e23-2e72-38c4-4a58-9b54942a466c}">
           <p14:sldIdLst>
             <p14:sldId id="256"/>
           </p14:sldIdLst>
         </p14:section>
-        <p14:section name="Old way" id="{96f5586f-aa02-7dfb-86c0-41356d61511e}">
+        <p14:section name="Old way" id="{1b0f4471-256d-0530-b8e5-3f92e578a404}">
           <p14:sldIdLst>
             <p14:sldId id="257"/>
           </p14:sldIdLst>
         </p14:section>
-        <p14:section name="HubAI" id="{18824608-126c-a816-bbcd-402ff8b9408a}">
+        <p14:section name="HubAI" id="{b3af4646-aa03-3a4b-fce8-fe0f413b7c4a}">
           <p14:sldIdLst>
             <p14:sldId id="258"/>
           </p14:sldIdLst>
         </p14:section>
-        <p14:section name="About me" id="{46e763e6-72c3-db26-018d-4df52d4263e4}">
+        <p14:section name="About me" id="{c7ff525f-e590-b900-0f06-e2e470a5605a}">
           <p14:sldIdLst>
             <p14:sldId id="259"/>
           </p14:sldIdLst>
@@ -1837,7 +1837,7 @@
                   <a:schemeClr val="accent5"/>
                 </a:solidFill>
               </a:rPr>
-              <a:t>Planning began Friday daytime; first commit 17:46</a:t>
+              <a:t>HubAI: first commit Saturday 10:37; built during the hackathon</a:t>
             </a:r>
             <a:endParaRPr lang="en-US" sz="1100" dirty="0"/>
           </a:p>

</xml_diff>